<commit_message>
Before stopping to support units
</commit_message>
<xml_diff>
--- a/vignettes/articles/figs_jdr/sdbuildR_paper.pptx
+++ b/vignettes/articles/figs_jdr/sdbuildR_paper.pptx
@@ -309,7 +309,7 @@
           <a:p>
             <a:fld id="{5BCAD085-E8A6-8845-BD4E-CB4CCA059FC4}" type="datetimeFigureOut">
               <a:rPr lang="en-US" smtClean="0"/>
-              <a:t>5/7/2026</a:t>
+              <a:t>5/15/2026</a:t>
             </a:fld>
             <a:endParaRPr lang="en-US"/>
           </a:p>
@@ -477,7 +477,7 @@
           <a:p>
             <a:fld id="{5BCAD085-E8A6-8845-BD4E-CB4CCA059FC4}" type="datetimeFigureOut">
               <a:rPr lang="en-US" smtClean="0"/>
-              <a:t>5/7/2026</a:t>
+              <a:t>5/15/2026</a:t>
             </a:fld>
             <a:endParaRPr lang="en-US"/>
           </a:p>
@@ -655,7 +655,7 @@
           <a:p>
             <a:fld id="{5BCAD085-E8A6-8845-BD4E-CB4CCA059FC4}" type="datetimeFigureOut">
               <a:rPr lang="en-US" smtClean="0"/>
-              <a:t>5/7/2026</a:t>
+              <a:t>5/15/2026</a:t>
             </a:fld>
             <a:endParaRPr lang="en-US"/>
           </a:p>
@@ -823,7 +823,7 @@
           <a:p>
             <a:fld id="{5BCAD085-E8A6-8845-BD4E-CB4CCA059FC4}" type="datetimeFigureOut">
               <a:rPr lang="en-US" smtClean="0"/>
-              <a:t>5/7/2026</a:t>
+              <a:t>5/15/2026</a:t>
             </a:fld>
             <a:endParaRPr lang="en-US"/>
           </a:p>
@@ -1068,7 +1068,7 @@
           <a:p>
             <a:fld id="{5BCAD085-E8A6-8845-BD4E-CB4CCA059FC4}" type="datetimeFigureOut">
               <a:rPr lang="en-US" smtClean="0"/>
-              <a:t>5/7/2026</a:t>
+              <a:t>5/15/2026</a:t>
             </a:fld>
             <a:endParaRPr lang="en-US"/>
           </a:p>
@@ -1353,7 +1353,7 @@
           <a:p>
             <a:fld id="{5BCAD085-E8A6-8845-BD4E-CB4CCA059FC4}" type="datetimeFigureOut">
               <a:rPr lang="en-US" smtClean="0"/>
-              <a:t>5/7/2026</a:t>
+              <a:t>5/15/2026</a:t>
             </a:fld>
             <a:endParaRPr lang="en-US"/>
           </a:p>
@@ -1772,7 +1772,7 @@
           <a:p>
             <a:fld id="{5BCAD085-E8A6-8845-BD4E-CB4CCA059FC4}" type="datetimeFigureOut">
               <a:rPr lang="en-US" smtClean="0"/>
-              <a:t>5/7/2026</a:t>
+              <a:t>5/15/2026</a:t>
             </a:fld>
             <a:endParaRPr lang="en-US"/>
           </a:p>
@@ -1889,7 +1889,7 @@
           <a:p>
             <a:fld id="{5BCAD085-E8A6-8845-BD4E-CB4CCA059FC4}" type="datetimeFigureOut">
               <a:rPr lang="en-US" smtClean="0"/>
-              <a:t>5/7/2026</a:t>
+              <a:t>5/15/2026</a:t>
             </a:fld>
             <a:endParaRPr lang="en-US"/>
           </a:p>
@@ -1984,7 +1984,7 @@
           <a:p>
             <a:fld id="{5BCAD085-E8A6-8845-BD4E-CB4CCA059FC4}" type="datetimeFigureOut">
               <a:rPr lang="en-US" smtClean="0"/>
-              <a:t>5/7/2026</a:t>
+              <a:t>5/15/2026</a:t>
             </a:fld>
             <a:endParaRPr lang="en-US"/>
           </a:p>
@@ -2259,7 +2259,7 @@
           <a:p>
             <a:fld id="{5BCAD085-E8A6-8845-BD4E-CB4CCA059FC4}" type="datetimeFigureOut">
               <a:rPr lang="en-US" smtClean="0"/>
-              <a:t>5/7/2026</a:t>
+              <a:t>5/15/2026</a:t>
             </a:fld>
             <a:endParaRPr lang="en-US"/>
           </a:p>
@@ -2511,7 +2511,7 @@
           <a:p>
             <a:fld id="{5BCAD085-E8A6-8845-BD4E-CB4CCA059FC4}" type="datetimeFigureOut">
               <a:rPr lang="en-US" smtClean="0"/>
-              <a:t>5/7/2026</a:t>
+              <a:t>5/15/2026</a:t>
             </a:fld>
             <a:endParaRPr lang="en-US"/>
           </a:p>
@@ -2722,7 +2722,7 @@
           <a:p>
             <a:fld id="{5BCAD085-E8A6-8845-BD4E-CB4CCA059FC4}" type="datetimeFigureOut">
               <a:rPr lang="en-US" smtClean="0"/>
-              <a:t>5/7/2026</a:t>
+              <a:t>5/15/2026</a:t>
             </a:fld>
             <a:endParaRPr lang="en-US"/>
           </a:p>
@@ -8400,7 +8400,7 @@
                 <a:ea typeface="Lato" panose="020F0502020204030203" pitchFamily="34" charset="0"/>
                 <a:cs typeface="Lato" panose="020F0502020204030203" pitchFamily="34" charset="0"/>
               </a:rPr>
-              <a:t>Energy</a:t>
+              <a:t>Engagement</a:t>
             </a:r>
             <a:br>
               <a:rPr lang="en-US" dirty="0">
@@ -8502,7 +8502,7 @@
                 <a:ea typeface="Lato" panose="020F0502020204030203" pitchFamily="34" charset="0"/>
                 <a:cs typeface="Lato" panose="020F0502020204030203" pitchFamily="34" charset="0"/>
               </a:rPr>
-              <a:t>Energy</a:t>
+              <a:t>Engagement</a:t>
             </a:r>
             <a:br>
               <a:rPr lang="en-US" dirty="0">
@@ -9045,7 +9045,7 @@
                 <a:ea typeface="Lato" panose="020F0502020204030203" pitchFamily="34" charset="0"/>
                 <a:cs typeface="Lato" panose="020F0502020204030203" pitchFamily="34" charset="0"/>
               </a:rPr>
-              <a:t>1.34</a:t>
+              <a:t>0.70</a:t>
             </a:r>
             <a:endParaRPr lang="en-NL" dirty="0">
               <a:solidFill>
@@ -9095,7 +9095,7 @@
                 <a:ea typeface="Lato" panose="020F0502020204030203" pitchFamily="34" charset="0"/>
                 <a:cs typeface="Lato" panose="020F0502020204030203" pitchFamily="34" charset="0"/>
               </a:rPr>
-              <a:t>1.34</a:t>
+              <a:t>0.01</a:t>
             </a:r>
             <a:endParaRPr lang="en-NL" dirty="0">
               <a:solidFill>
@@ -9145,7 +9145,7 @@
                 <a:ea typeface="Lato" panose="020F0502020204030203" pitchFamily="34" charset="0"/>
                 <a:cs typeface="Lato" panose="020F0502020204030203" pitchFamily="34" charset="0"/>
               </a:rPr>
-              <a:t>1.34</a:t>
+              <a:t>0.48</a:t>
             </a:r>
             <a:endParaRPr lang="en-NL" dirty="0">
               <a:solidFill>
@@ -9172,8 +9172,8 @@
         </p:nvSpPr>
         <p:spPr>
           <a:xfrm>
-            <a:off x="1905668" y="1646828"/>
-            <a:ext cx="740228" cy="369332"/>
+            <a:off x="1816749" y="1646828"/>
+            <a:ext cx="829147" cy="369332"/>
           </a:xfrm>
           <a:prstGeom prst="rect">
             <a:avLst/>
@@ -9195,7 +9195,7 @@
                 <a:ea typeface="Lato" panose="020F0502020204030203" pitchFamily="34" charset="0"/>
                 <a:cs typeface="Lato" panose="020F0502020204030203" pitchFamily="34" charset="0"/>
               </a:rPr>
-              <a:t>1.34</a:t>
+              <a:t>-0.21</a:t>
             </a:r>
             <a:endParaRPr lang="en-NL" dirty="0">
               <a:solidFill>

</xml_diff>